<commit_message>
Close the gaps in what CP7 tells students to build
An audit of each CP7 item against the handout, checklist, and the
Session 15-16 materials found one error and several gaps.

- LICENSE: fill in fields only if the license has them (MIT, BSD).
  Apache's [yyyy] [name] line is a file-header template and stays,
  as Prop Loft's does; the deck notes no longer flag it.
- Code of conduct: what a working reporting contact needs (an
  address you'll check, a response time, and a route for reports
  about the maintainer), which the rubric already grades.
- CONTRIBUTING links to docs/setup.md instead of repeating setup.
- Handout: what a PR template holds; "how decisions get made" in
  the norms; which form a task-type seed issue uses; and review on
  a solo project means a written self-review.

Co-Authored-By: Claude Opus 5.5 (1M context) <noreply@anthropic.com>
</commit_message>
<xml_diff>
--- a/canvas_material/lectures/powerpoint/Session16-FrontDoorWorkshop.pptx
+++ b/canvas_material/lectures/powerpoint/Session16-FrontDoorWorkshop.pptx
@@ -1040,7 +1040,7 @@
           <a:p>
             <a:r>
               <a:rPr lang="en-US" dirty="0"/>
-              <a:t>Twenty minutes, one small PR per item. Rove hard. Spot-check license fields (wrong year and 'Copyright [yyyy] [name]' left in are the common misses). Read README first sentences back to their authors: would a stranger know what this is? The placeholder takes five minutes; don't let anyone write real setup steps for code that doesn't exist yet. That guide comes in Session 20. Warn at ten minutes and at two.</a:t>
+              <a:t>Twenty minutes, one small PR per item. Rove hard. Spot-check license fields: MIT and BSD need a year and holder; Apache's '[yyyy] [name of copyright owner]' line is a file-header template in the appendix and stays as written, so don't flag it. Check reporting contacts: an address they'll actually read, a response time, and, solo, GitHub's reporting tools for reports about the maintainer. Read README first sentences back to their authors: would a stranger know what this is? The placeholder takes five minutes; don't let anyone write real setup steps for code that doesn't exist yet. That guide comes in Session 20. Warn at ten minutes and at two.</a:t>
             </a:r>
             <a:endParaRPr lang="en-US" dirty="0"/>
           </a:p>
@@ -6919,7 +6919,7 @@
                 <a:ea typeface="Calibri" pitchFamily="34" charset="-122"/>
                 <a:cs typeface="Calibri" pitchFamily="34" charset="-120"/>
               </a:rPr>
-              <a:t>The exact text. Year and holder filled in. Rationale goes in CONTRIBUTING.</a:t>
+              <a:t>The exact text. Fill in fields only if it has them (MIT, BSD). Rationale goes in CONTRIBUTING.</a:t>
             </a:r>
             <a:endParaRPr lang="en-US" sz="1500" dirty="0"/>
           </a:p>
@@ -7070,7 +7070,7 @@
                 <a:ea typeface="Calibri" pitchFamily="34" charset="-122"/>
                 <a:cs typeface="Calibri" pitchFamily="34" charset="-120"/>
               </a:rPr>
-              <a:t>Contributor Covenant via GitHub's template. Fill in the reporting contact; read the enforcement section.</a:t>
+              <a:t>Contributor Covenant, adopted. A contact you'll check, a response time, and a route if it's about you.</a:t>
             </a:r>
             <a:endParaRPr lang="en-US" sz="1500" dirty="0"/>
           </a:p>

</xml_diff>

<commit_message>
Update session 16 material
</commit_message>
<xml_diff>
--- a/canvas_material/lectures/powerpoint/Session16-FrontDoorWorkshop.pptx
+++ b/canvas_material/lectures/powerpoint/Session16-FrontDoorWorkshop.pptx
@@ -6586,7 +6586,7 @@
                 <a:ea typeface="Calibri" pitchFamily="34" charset="-122"/>
                 <a:cs typeface="Calibri" pitchFamily="34" charset="-120"/>
               </a:rPr>
-              <a:t>Under ten minutes: fix it now. Bigger: file an issue. Either way, write the number on the sheet and say "from the stranger's read" in the description.</a:t>
+              <a:t>Under ten minutes: fix it now. Bigger: file an issue. Write the number on the sheet and say "from the stranger's read" in the description. Keep the sheet: finish the rest by Friday and photograph it for CP7.</a:t>
             </a:r>
             <a:endParaRPr lang="en-US" sz="1550" dirty="0"/>
           </a:p>
@@ -6894,7 +6894,7 @@
                 <a:ea typeface="Calibri" pitchFamily="34" charset="-122"/>
                 <a:cs typeface="Calibri" pitchFamily="34" charset="-120"/>
               </a:rPr>
-              <a:t>Review your partner's open PRs. Unfinished fixes carry to Friday; that's what the sheet is for.</a:t>
+              <a:t>Review your partner's open PRs. A real review comment is CP9 evidence; save the link.</a:t>
             </a:r>
             <a:endParaRPr lang="en-US" sz="1550" dirty="0"/>
           </a:p>

</xml_diff>